<commit_message>
updated rote for limit chek
</commit_message>
<xml_diff>
--- a/Ampera AI Governance - Presentation.pptx
+++ b/Ampera AI Governance - Presentation.pptx
@@ -4743,7 +4743,74 @@
       <p:grpSpPr/>
       <p:sp>
         <p:nvSpPr>
-          <p:cNvPr id="2" name="TextBox 1"/>
+          <p:cNvPr id="1" name="Right Triangle 8"/>
+          <p:cNvSpPr/>
+          <p:nvPr/>
+        </p:nvSpPr>
+        <p:spPr>
+          <a:xfrm rot="10800000" flipH="1">
+            <a:off x="1" y="-4"/>
+            <a:ext cx="838200" cy="6858003"/>
+          </a:xfrm>
+          <a:prstGeom prst="rtTriangle">
+            <a:avLst/>
+          </a:prstGeom>
+          <a:ln>
+            <a:noFill/>
+          </a:ln>
+        </p:spPr>
+        <p:style>
+          <a:lnRef idx="2">
+            <a:schemeClr val="accent1">
+              <a:shade val="15000"/>
+            </a:schemeClr>
+          </a:lnRef>
+          <a:fillRef idx="1">
+            <a:schemeClr val="accent1"/>
+          </a:fillRef>
+          <a:effectRef idx="0">
+            <a:schemeClr val="accent1"/>
+          </a:effectRef>
+          <a:fontRef idx="minor">
+            <a:schemeClr val="lt1"/>
+          </a:fontRef>
+        </p:style>
+        <p:txBody>
+          <a:bodyPr rtlCol="0" anchor="ctr"/>
+          <a:lstStyle/>
+          <a:p/>
+        </p:txBody>
+      </p:sp>
+      <p:sp>
+        <p:nvSpPr>
+          <p:cNvPr id="2" name="Right Triangle 9"/>
+          <p:cNvSpPr/>
+          <p:nvPr/>
+        </p:nvSpPr>
+        <p:spPr>
+          <a:xfrm>
+            <a:off x="-1" y="1066800"/>
+            <a:ext cx="838201" cy="5796024"/>
+          </a:xfrm>
+          <a:prstGeom prst="rtTriangle">
+            <a:avLst/>
+          </a:prstGeom>
+          <a:solidFill>
+            <a:schemeClr val="accent4"/>
+          </a:solidFill>
+          <a:ln>
+            <a:noFill/>
+          </a:ln>
+        </p:spPr>
+        <p:txBody>
+          <a:bodyPr rtlCol="0" anchor="ctr"/>
+          <a:lstStyle/>
+          <a:p/>
+        </p:txBody>
+      </p:sp>
+      <p:sp>
+        <p:nvSpPr>
+          <p:cNvPr id="3" name="TextBox 2"/>
           <p:cNvSpPr txBox="1"/>
           <p:nvPr/>
         </p:nvSpPr>
@@ -4778,7 +4845,7 @@
       </p:sp>
       <p:sp>
         <p:nvSpPr>
-          <p:cNvPr id="3" name="TextBox 2"/>
+          <p:cNvPr id="4" name="TextBox 3"/>
           <p:cNvSpPr txBox="1"/>
           <p:nvPr/>
         </p:nvSpPr>
@@ -4813,7 +4880,7 @@
       </p:sp>
       <p:sp>
         <p:nvSpPr>
-          <p:cNvPr id="4" name="TextBox 3"/>
+          <p:cNvPr id="5" name="TextBox 4"/>
           <p:cNvSpPr txBox="1"/>
           <p:nvPr/>
         </p:nvSpPr>
@@ -5741,6 +5808,73 @@
       <p:grpSpPr/>
       <p:sp>
         <p:nvSpPr>
+          <p:cNvPr id="5" name="Right Triangle 8"/>
+          <p:cNvSpPr/>
+          <p:nvPr/>
+        </p:nvSpPr>
+        <p:spPr>
+          <a:xfrm rot="10800000" flipH="1">
+            <a:off x="1" y="-4"/>
+            <a:ext cx="838200" cy="6858003"/>
+          </a:xfrm>
+          <a:prstGeom prst="rtTriangle">
+            <a:avLst/>
+          </a:prstGeom>
+          <a:ln>
+            <a:noFill/>
+          </a:ln>
+        </p:spPr>
+        <p:style>
+          <a:lnRef idx="2">
+            <a:schemeClr val="accent1">
+              <a:shade val="15000"/>
+            </a:schemeClr>
+          </a:lnRef>
+          <a:fillRef idx="1">
+            <a:schemeClr val="accent1"/>
+          </a:fillRef>
+          <a:effectRef idx="0">
+            <a:schemeClr val="accent1"/>
+          </a:effectRef>
+          <a:fontRef idx="minor">
+            <a:schemeClr val="lt1"/>
+          </a:fontRef>
+        </p:style>
+        <p:txBody>
+          <a:bodyPr rtlCol="0" anchor="ctr"/>
+          <a:lstStyle/>
+          <a:p/>
+        </p:txBody>
+      </p:sp>
+      <p:sp>
+        <p:nvSpPr>
+          <p:cNvPr id="6" name="Right Triangle 9"/>
+          <p:cNvSpPr/>
+          <p:nvPr/>
+        </p:nvSpPr>
+        <p:spPr>
+          <a:xfrm>
+            <a:off x="-1" y="1066800"/>
+            <a:ext cx="838201" cy="5796024"/>
+          </a:xfrm>
+          <a:prstGeom prst="rtTriangle">
+            <a:avLst/>
+          </a:prstGeom>
+          <a:solidFill>
+            <a:schemeClr val="accent4"/>
+          </a:solidFill>
+          <a:ln>
+            <a:noFill/>
+          </a:ln>
+        </p:spPr>
+        <p:txBody>
+          <a:bodyPr rtlCol="0" anchor="ctr"/>
+          <a:lstStyle/>
+          <a:p/>
+        </p:txBody>
+      </p:sp>
+      <p:sp>
+        <p:nvSpPr>
           <p:cNvPr id="2" name="Title 1"/>
           <p:cNvSpPr>
             <a:spLocks noGrp="1"/>
@@ -5948,6 +6082,30 @@
           <a:p/>
         </p:txBody>
       </p:sp>
+      <p:pic>
+        <p:nvPicPr>
+          <p:cNvPr id="7" name="Picture 6" descr="image.jpeg"/>
+          <p:cNvPicPr>
+            <a:picLocks noChangeAspect="1"/>
+          </p:cNvPicPr>
+          <p:nvPr/>
+        </p:nvPicPr>
+        <p:blipFill>
+          <a:blip r:embed="rId2"/>
+          <a:stretch>
+            <a:fillRect/>
+          </a:stretch>
+        </p:blipFill>
+        <p:spPr>
+          <a:xfrm>
+            <a:off x="10506456" y="18288"/>
+            <a:ext cx="1691640" cy="448056"/>
+          </a:xfrm>
+          <a:prstGeom prst="rect">
+            <a:avLst/>
+          </a:prstGeom>
+        </p:spPr>
+      </p:pic>
     </p:spTree>
   </p:cSld>
   <p:clrMapOvr>

</xml_diff>

<commit_message>
updated modal deployment for gpt 4o
</commit_message>
<xml_diff>
--- a/Ampera AI Governance - Presentation.pptx
+++ b/Ampera AI Governance - Presentation.pptx
@@ -4977,16 +4977,16 @@
       </p:sp>
       <p:sp>
         <p:nvSpPr>
-          <p:cNvPr id="4" name="Rectangle 3"/>
+          <p:cNvPr id="4" name="Rounded Rectangle 3"/>
           <p:cNvSpPr/>
           <p:nvPr/>
         </p:nvSpPr>
         <p:spPr>
           <a:xfrm>
-            <a:off x="1051560" y="2148840"/>
-            <a:ext cx="1783080" cy="1645920"/>
+            <a:off x="838200" y="2150000"/>
+            <a:ext cx="1500000" cy="1350000"/>
           </a:xfrm>
-          <a:prstGeom prst="rect">
+          <a:prstGeom prst="roundRect">
             <a:avLst/>
           </a:prstGeom>
           <a:solidFill>
@@ -4997,6 +4997,7 @@
               <a:srgbClr val="AC9BE9"/>
             </a:solidFill>
           </a:ln>
+          <a:effectLst/>
         </p:spPr>
         <p:style>
           <a:lnRef idx="1">
@@ -5013,19 +5014,18 @@
           </a:fontRef>
         </p:style>
         <p:txBody>
-          <a:bodyPr rtlCol="0" anchor="ctr" wrap="square" lIns="73152" rIns="73152"/>
+          <a:bodyPr rtlCol="0" anchor="ctr" wrap="square" lIns="45720" rIns="45720" tIns="22860" bIns="22860"/>
           <a:lstStyle/>
           <a:p>
             <a:pPr algn="ctr"/>
             <a:r>
-              <a:rPr sz="1000" b="1">
+              <a:rPr sz="1100" b="1">
                 <a:solidFill>
                   <a:srgbClr val="95135A"/>
                 </a:solidFill>
                 <a:latin typeface="Open Sans"/>
               </a:rPr>
-              <a:t>Client
-Teams</a:t>
+              <a:t>Client Teams</a:t>
             </a:r>
           </a:p>
           <a:p>
@@ -5037,7 +5037,7 @@
                 </a:solidFill>
                 <a:latin typeface="Open Sans"/>
               </a:rPr>
-              <a:t>Enterprise apps,</a:t>
+              <a:t>Enterprise apps, internal</a:t>
             </a:r>
           </a:p>
           <a:p>
@@ -5049,7 +5049,7 @@
                 </a:solidFill>
                 <a:latin typeface="Open Sans"/>
               </a:rPr>
-              <a:t>internal tools &amp;</a:t>
+              <a:t>tools &amp; AI consumers send</a:t>
             </a:r>
           </a:p>
           <a:p>
@@ -5061,31 +5061,34 @@
                 </a:solidFill>
                 <a:latin typeface="Open Sans"/>
               </a:rPr>
-              <a:t>AI consumers</a:t>
-            </a:r>
-          </a:p>
-        </p:txBody>
-      </p:sp>
-      <p:sp>
-        <p:nvSpPr>
-          <p:cNvPr id="5" name="Can 4"/>
+              <a:t>a request with their key</a:t>
+            </a:r>
+          </a:p>
+        </p:txBody>
+      </p:sp>
+      <p:sp>
+        <p:nvSpPr>
+          <p:cNvPr id="5" name="Rounded Rectangle 4"/>
           <p:cNvSpPr/>
           <p:nvPr/>
         </p:nvSpPr>
         <p:spPr>
           <a:xfrm>
-            <a:off x="2907792" y="2889503"/>
-            <a:ext cx="347472" cy="228600"/>
+            <a:off x="2588200" y="2150000"/>
+            <a:ext cx="6815600" cy="1350000"/>
           </a:xfrm>
-          <a:prstGeom prst="can">
+          <a:prstGeom prst="roundRect">
             <a:avLst/>
           </a:prstGeom>
           <a:solidFill>
-            <a:srgbClr val="95135A"/>
+            <a:srgbClr val="F8F0FF"/>
           </a:solidFill>
-          <a:ln>
-            <a:noFill/>
+          <a:ln w="12700">
+            <a:solidFill>
+              <a:srgbClr val="95135A"/>
+            </a:solidFill>
           </a:ln>
+          <a:effectLst/>
         </p:spPr>
         <p:style>
           <a:lnRef idx="1">
@@ -5102,35 +5105,45 @@
           </a:fontRef>
         </p:style>
         <p:txBody>
-          <a:bodyPr rtlCol="0" anchor="ctr"/>
+          <a:bodyPr rtlCol="0" anchor="ctr" wrap="square" lIns="45720" rIns="45720" tIns="22860" bIns="22860"/>
           <a:lstStyle/>
           <a:p>
             <a:pPr algn="ctr"/>
-          </a:p>
-        </p:txBody>
-      </p:sp>
-      <p:sp>
-        <p:nvSpPr>
-          <p:cNvPr id="6" name="Rectangle 5"/>
+            <a:r>
+              <a:rPr sz="100" b="0">
+                <a:solidFill>
+                  <a:srgbClr val="454551"/>
+                </a:solidFill>
+                <a:latin typeface="Open Sans"/>
+              </a:rPr>
+              <a:t/>
+            </a:r>
+          </a:p>
+        </p:txBody>
+      </p:sp>
+      <p:sp>
+        <p:nvSpPr>
+          <p:cNvPr id="6" name="Rounded Rectangle 5"/>
           <p:cNvSpPr/>
           <p:nvPr/>
         </p:nvSpPr>
         <p:spPr>
           <a:xfrm>
-            <a:off x="3337560" y="1737360"/>
-            <a:ext cx="4754880" cy="2468880"/>
+            <a:off x="9653800" y="2150000"/>
+            <a:ext cx="1700000" cy="1350000"/>
           </a:xfrm>
-          <a:prstGeom prst="rect">
+          <a:prstGeom prst="roundRect">
             <a:avLst/>
           </a:prstGeom>
           <a:solidFill>
-            <a:srgbClr val="F8F0FF"/>
+            <a:srgbClr val="F5F0FF"/>
           </a:solidFill>
           <a:ln w="12700">
             <a:solidFill>
-              <a:srgbClr val="95135A"/>
+              <a:srgbClr val="AC9BE9"/>
             </a:solidFill>
           </a:ln>
+          <a:effectLst/>
         </p:spPr>
         <p:style>
           <a:lnRef idx="1">
@@ -5147,7 +5160,7 @@
           </a:fontRef>
         </p:style>
         <p:txBody>
-          <a:bodyPr rtlCol="0" anchor="ctr" wrap="square" lIns="73152" rIns="73152"/>
+          <a:bodyPr rtlCol="0" anchor="ctr" wrap="square" lIns="45720" rIns="45720" tIns="22860" bIns="22860"/>
           <a:lstStyle/>
           <a:p>
             <a:pPr algn="ctr"/>
@@ -5158,91 +5171,105 @@
                 </a:solidFill>
                 <a:latin typeface="Open Sans"/>
               </a:rPr>
-              <a:t>AI Governance Platform</a:t>
+              <a:t>AI Provider</a:t>
             </a:r>
           </a:p>
           <a:p>
             <a:pPr algn="ctr"/>
             <a:r>
-              <a:rPr sz="850" b="0">
+              <a:rPr sz="800" b="0">
                 <a:solidFill>
                   <a:srgbClr val="454551"/>
                 </a:solidFill>
                 <a:latin typeface="Open Sans"/>
               </a:rPr>
-              <a:t>────────────────────</a:t>
+              <a:t>Securely processes only</a:t>
             </a:r>
           </a:p>
           <a:p>
             <a:pPr algn="ctr"/>
             <a:r>
-              <a:rPr sz="850" b="0">
+              <a:rPr sz="800" b="0">
                 <a:solidFill>
                   <a:srgbClr val="454551"/>
                 </a:solidFill>
                 <a:latin typeface="Open Sans"/>
               </a:rPr>
-              <a:t>Policy &amp; Access Control</a:t>
+              <a:t>the approved, sanitized</a:t>
             </a:r>
           </a:p>
           <a:p>
             <a:pPr algn="ctr"/>
             <a:r>
-              <a:rPr sz="850" b="0">
+              <a:rPr sz="800" b="0">
                 <a:solidFill>
                   <a:srgbClr val="454551"/>
                 </a:solidFill>
                 <a:latin typeface="Open Sans"/>
               </a:rPr>
-              <a:t>PII Protection</a:t>
-            </a:r>
-          </a:p>
+              <a:t>request</a:t>
+            </a:r>
+          </a:p>
+        </p:txBody>
+      </p:sp>
+      <p:sp>
+        <p:nvSpPr>
+          <p:cNvPr id="7" name="TextBox 6"/>
+          <p:cNvSpPr txBox="1"/>
+          <p:nvPr/>
+        </p:nvSpPr>
+        <p:spPr>
+          <a:xfrm>
+            <a:off x="2588200" y="2210000"/>
+            <a:ext cx="6815600" cy="380000"/>
+          </a:xfrm>
+          <a:prstGeom prst="rect">
+            <a:avLst/>
+          </a:prstGeom>
+          <a:noFill/>
+        </p:spPr>
+        <p:txBody>
+          <a:bodyPr wrap="square">
+            <a:spAutoFit/>
+          </a:bodyPr>
+          <a:lstStyle/>
           <a:p>
             <a:pPr algn="ctr"/>
             <a:r>
-              <a:rPr sz="850" b="0">
+              <a:rPr sz="1050" b="1">
                 <a:solidFill>
-                  <a:srgbClr val="454551"/>
+                  <a:srgbClr val="95135A"/>
                 </a:solidFill>
                 <a:latin typeface="Open Sans"/>
               </a:rPr>
-              <a:t>Budget &amp; Rate Limiting</a:t>
-            </a:r>
-          </a:p>
-          <a:p>
-            <a:pPr algn="ctr"/>
-            <a:r>
-              <a:rPr sz="850" b="0">
-                <a:solidFill>
-                  <a:srgbClr val="454551"/>
-                </a:solidFill>
-                <a:latin typeface="Open Sans"/>
-              </a:rPr>
-              <a:t>Audit Logging</a:t>
-            </a:r>
-          </a:p>
-        </p:txBody>
-      </p:sp>
-      <p:sp>
-        <p:nvSpPr>
-          <p:cNvPr id="7" name="Can 6"/>
+              <a:t>Governance Gateway — every request passes through these checks, in order</a:t>
+            </a:r>
+          </a:p>
+        </p:txBody>
+      </p:sp>
+      <p:sp>
+        <p:nvSpPr>
+          <p:cNvPr id="8" name="Rounded Rectangle 7"/>
           <p:cNvSpPr/>
           <p:nvPr/>
         </p:nvSpPr>
         <p:spPr>
           <a:xfrm>
-            <a:off x="8165592" y="2889503"/>
-            <a:ext cx="347472" cy="228600"/>
+            <a:off x="2738200" y="2630000"/>
+            <a:ext cx="1183120" cy="780000"/>
           </a:xfrm>
-          <a:prstGeom prst="can">
+          <a:prstGeom prst="roundRect">
             <a:avLst/>
           </a:prstGeom>
           <a:solidFill>
-            <a:srgbClr val="95135A"/>
+            <a:srgbClr val="FFFFFF"/>
           </a:solidFill>
-          <a:ln>
-            <a:noFill/>
+          <a:ln w="9525">
+            <a:solidFill>
+              <a:srgbClr val="8971E1"/>
+            </a:solidFill>
           </a:ln>
+          <a:effectLst/>
         </p:spPr>
         <p:style>
           <a:lnRef idx="1">
@@ -5259,35 +5286,55 @@
           </a:fontRef>
         </p:style>
         <p:txBody>
-          <a:bodyPr rtlCol="0" anchor="ctr"/>
+          <a:bodyPr rtlCol="0" anchor="ctr" wrap="square" lIns="45720" rIns="45720" tIns="22860" bIns="22860"/>
           <a:lstStyle/>
           <a:p>
             <a:pPr algn="ctr"/>
-          </a:p>
-        </p:txBody>
-      </p:sp>
-      <p:sp>
-        <p:nvSpPr>
-          <p:cNvPr id="8" name="Rectangle 7"/>
+            <a:r>
+              <a:rPr sz="850" b="1">
+                <a:solidFill>
+                  <a:srgbClr val="95135A"/>
+                </a:solidFill>
+                <a:latin typeface="Open Sans"/>
+              </a:rPr>
+              <a:t>Identify &amp; Access</a:t>
+            </a:r>
+          </a:p>
+          <a:p>
+            <a:pPr algn="ctr"/>
+            <a:r>
+              <a:rPr sz="650" b="0">
+                <a:solidFill>
+                  <a:srgbClr val="454551"/>
+                </a:solidFill>
+                <a:latin typeface="Open Sans"/>
+              </a:rPr>
+              <a:t>Resolve which org &amp; project the request belongs to</a:t>
+            </a:r>
+          </a:p>
+        </p:txBody>
+      </p:sp>
+      <p:sp>
+        <p:nvSpPr>
+          <p:cNvPr id="9" name="Right Arrow 8"/>
           <p:cNvSpPr/>
           <p:nvPr/>
         </p:nvSpPr>
         <p:spPr>
           <a:xfrm>
-            <a:off x="8595360" y="2148840"/>
-            <a:ext cx="2011680" cy="1645920"/>
+            <a:off x="3921320" y="2975000"/>
+            <a:ext cx="150000" cy="90000"/>
           </a:xfrm>
-          <a:prstGeom prst="rect">
+          <a:prstGeom prst="rightArrow">
             <a:avLst/>
           </a:prstGeom>
           <a:solidFill>
-            <a:srgbClr val="F5F0FF"/>
+            <a:srgbClr val="8971E1"/>
           </a:solidFill>
-          <a:ln w="12700">
-            <a:solidFill>
-              <a:srgbClr val="AC9BE9"/>
-            </a:solidFill>
+          <a:ln>
+            <a:noFill/>
           </a:ln>
+          <a:effectLst/>
         </p:spPr>
         <p:style>
           <a:lnRef idx="1">
@@ -5304,79 +5351,36 @@
           </a:fontRef>
         </p:style>
         <p:txBody>
-          <a:bodyPr rtlCol="0" anchor="ctr" wrap="square" lIns="73152" rIns="73152"/>
+          <a:bodyPr rtlCol="0" anchor="ctr"/>
           <a:lstStyle/>
           <a:p>
             <a:pPr algn="ctr"/>
-            <a:r>
-              <a:rPr sz="1000" b="1">
-                <a:solidFill>
-                  <a:srgbClr val="95135A"/>
-                </a:solidFill>
-                <a:latin typeface="Open Sans"/>
-              </a:rPr>
-              <a:t>AI Provider
-(Azure OpenAI)</a:t>
-            </a:r>
-          </a:p>
-          <a:p>
-            <a:pPr algn="ctr"/>
-            <a:r>
-              <a:rPr sz="800" b="0">
-                <a:solidFill>
-                  <a:srgbClr val="454551"/>
-                </a:solidFill>
-                <a:latin typeface="Open Sans"/>
-              </a:rPr>
-              <a:t>Processes</a:t>
-            </a:r>
-          </a:p>
-          <a:p>
-            <a:pPr algn="ctr"/>
-            <a:r>
-              <a:rPr sz="800" b="0">
-                <a:solidFill>
-                  <a:srgbClr val="454551"/>
-                </a:solidFill>
-                <a:latin typeface="Open Sans"/>
-              </a:rPr>
-              <a:t>approved AI</a:t>
-            </a:r>
-          </a:p>
-          <a:p>
-            <a:pPr algn="ctr"/>
-            <a:r>
-              <a:rPr sz="800" b="0">
-                <a:solidFill>
-                  <a:srgbClr val="454551"/>
-                </a:solidFill>
-                <a:latin typeface="Open Sans"/>
-              </a:rPr>
-              <a:t>requests</a:t>
-            </a:r>
-          </a:p>
-        </p:txBody>
-      </p:sp>
-      <p:sp>
-        <p:nvSpPr>
-          <p:cNvPr id="9" name="Cube 8"/>
+          </a:p>
+        </p:txBody>
+      </p:sp>
+      <p:sp>
+        <p:nvSpPr>
+          <p:cNvPr id="10" name="Rounded Rectangle 9"/>
           <p:cNvSpPr/>
           <p:nvPr/>
         </p:nvSpPr>
         <p:spPr>
           <a:xfrm>
-            <a:off x="5303520" y="4224528"/>
-            <a:ext cx="228600" cy="320040"/>
+            <a:off x="4071320" y="2630000"/>
+            <a:ext cx="1183120" cy="780000"/>
           </a:xfrm>
-          <a:prstGeom prst="cube">
+          <a:prstGeom prst="roundRect">
             <a:avLst/>
           </a:prstGeom>
           <a:solidFill>
-            <a:srgbClr val="8971E1"/>
+            <a:srgbClr val="FFFFFF"/>
           </a:solidFill>
-          <a:ln>
-            <a:noFill/>
+          <a:ln w="9525">
+            <a:solidFill>
+              <a:srgbClr val="8971E1"/>
+            </a:solidFill>
           </a:ln>
+          <a:effectLst/>
         </p:spPr>
         <p:style>
           <a:lnRef idx="1">
@@ -5393,35 +5397,55 @@
           </a:fontRef>
         </p:style>
         <p:txBody>
-          <a:bodyPr rtlCol="0" anchor="ctr"/>
+          <a:bodyPr rtlCol="0" anchor="ctr" wrap="square" lIns="45720" rIns="45720" tIns="22860" bIns="22860"/>
           <a:lstStyle/>
           <a:p>
             <a:pPr algn="ctr"/>
-          </a:p>
-        </p:txBody>
-      </p:sp>
-      <p:sp>
-        <p:nvSpPr>
-          <p:cNvPr id="10" name="Rectangle 9"/>
+            <a:r>
+              <a:rPr sz="850" b="1">
+                <a:solidFill>
+                  <a:srgbClr val="95135A"/>
+                </a:solidFill>
+                <a:latin typeface="Open Sans"/>
+              </a:rPr>
+              <a:t>Policy Rules</a:t>
+            </a:r>
+          </a:p>
+          <a:p>
+            <a:pPr algn="ctr"/>
+            <a:r>
+              <a:rPr sz="650" b="0">
+                <a:solidFill>
+                  <a:srgbClr val="454551"/>
+                </a:solidFill>
+                <a:latin typeface="Open Sans"/>
+              </a:rPr>
+              <a:t>Allow/block specific models &amp; enforce token limits</a:t>
+            </a:r>
+          </a:p>
+        </p:txBody>
+      </p:sp>
+      <p:sp>
+        <p:nvSpPr>
+          <p:cNvPr id="11" name="Right Arrow 10"/>
           <p:cNvSpPr/>
           <p:nvPr/>
         </p:nvSpPr>
         <p:spPr>
           <a:xfrm>
-            <a:off x="3337560" y="4544568"/>
-            <a:ext cx="4754880" cy="914400"/>
+            <a:off x="5254440" y="2975000"/>
+            <a:ext cx="150000" cy="90000"/>
           </a:xfrm>
-          <a:prstGeom prst="rect">
+          <a:prstGeom prst="rightArrow">
             <a:avLst/>
           </a:prstGeom>
           <a:solidFill>
-            <a:srgbClr val="ECE8FF"/>
+            <a:srgbClr val="8971E1"/>
           </a:solidFill>
-          <a:ln w="12700">
-            <a:solidFill>
-              <a:srgbClr val="8971E1"/>
-            </a:solidFill>
+          <a:ln>
+            <a:noFill/>
           </a:ln>
+          <a:effectLst/>
         </p:spPr>
         <p:style>
           <a:lnRef idx="1">
@@ -5438,12 +5462,692 @@
           </a:fontRef>
         </p:style>
         <p:txBody>
-          <a:bodyPr rtlCol="0" anchor="ctr" wrap="square" lIns="73152" rIns="73152"/>
+          <a:bodyPr rtlCol="0" anchor="ctr"/>
           <a:lstStyle/>
           <a:p>
             <a:pPr algn="ctr"/>
-            <a:r>
-              <a:rPr sz="1000" b="1">
+          </a:p>
+        </p:txBody>
+      </p:sp>
+      <p:sp>
+        <p:nvSpPr>
+          <p:cNvPr id="12" name="Rounded Rectangle 11"/>
+          <p:cNvSpPr/>
+          <p:nvPr/>
+        </p:nvSpPr>
+        <p:spPr>
+          <a:xfrm>
+            <a:off x="5404440" y="2630000"/>
+            <a:ext cx="1183120" cy="780000"/>
+          </a:xfrm>
+          <a:prstGeom prst="roundRect">
+            <a:avLst/>
+          </a:prstGeom>
+          <a:solidFill>
+            <a:srgbClr val="FFFFFF"/>
+          </a:solidFill>
+          <a:ln w="9525">
+            <a:solidFill>
+              <a:srgbClr val="8971E1"/>
+            </a:solidFill>
+          </a:ln>
+          <a:effectLst/>
+        </p:spPr>
+        <p:style>
+          <a:lnRef idx="1">
+            <a:schemeClr val="accent1"/>
+          </a:lnRef>
+          <a:fillRef idx="3">
+            <a:schemeClr val="accent1"/>
+          </a:fillRef>
+          <a:effectRef idx="2">
+            <a:schemeClr val="accent1"/>
+          </a:effectRef>
+          <a:fontRef idx="minor">
+            <a:schemeClr val="lt1"/>
+          </a:fontRef>
+        </p:style>
+        <p:txBody>
+          <a:bodyPr rtlCol="0" anchor="ctr" wrap="square" lIns="45720" rIns="45720" tIns="22860" bIns="22860"/>
+          <a:lstStyle/>
+          <a:p>
+            <a:pPr algn="ctr"/>
+            <a:r>
+              <a:rPr sz="850" b="1">
+                <a:solidFill>
+                  <a:srgbClr val="95135A"/>
+                </a:solidFill>
+                <a:latin typeface="Open Sans"/>
+              </a:rPr>
+              <a:t>Budget Limits</a:t>
+            </a:r>
+          </a:p>
+          <a:p>
+            <a:pPr algn="ctr"/>
+            <a:r>
+              <a:rPr sz="650" b="0">
+                <a:solidFill>
+                  <a:srgbClr val="454551"/>
+                </a:solidFill>
+                <a:latin typeface="Open Sans"/>
+              </a:rPr>
+              <a:t>Check monthly spend caps for org &amp; project</a:t>
+            </a:r>
+          </a:p>
+        </p:txBody>
+      </p:sp>
+      <p:sp>
+        <p:nvSpPr>
+          <p:cNvPr id="13" name="Right Arrow 12"/>
+          <p:cNvSpPr/>
+          <p:nvPr/>
+        </p:nvSpPr>
+        <p:spPr>
+          <a:xfrm>
+            <a:off x="6587560" y="2975000"/>
+            <a:ext cx="150000" cy="90000"/>
+          </a:xfrm>
+          <a:prstGeom prst="rightArrow">
+            <a:avLst/>
+          </a:prstGeom>
+          <a:solidFill>
+            <a:srgbClr val="8971E1"/>
+          </a:solidFill>
+          <a:ln>
+            <a:noFill/>
+          </a:ln>
+          <a:effectLst/>
+        </p:spPr>
+        <p:style>
+          <a:lnRef idx="1">
+            <a:schemeClr val="accent1"/>
+          </a:lnRef>
+          <a:fillRef idx="3">
+            <a:schemeClr val="accent1"/>
+          </a:fillRef>
+          <a:effectRef idx="2">
+            <a:schemeClr val="accent1"/>
+          </a:effectRef>
+          <a:fontRef idx="minor">
+            <a:schemeClr val="lt1"/>
+          </a:fontRef>
+        </p:style>
+        <p:txBody>
+          <a:bodyPr rtlCol="0" anchor="ctr"/>
+          <a:lstStyle/>
+          <a:p>
+            <a:pPr algn="ctr"/>
+          </a:p>
+        </p:txBody>
+      </p:sp>
+      <p:sp>
+        <p:nvSpPr>
+          <p:cNvPr id="14" name="Rounded Rectangle 13"/>
+          <p:cNvSpPr/>
+          <p:nvPr/>
+        </p:nvSpPr>
+        <p:spPr>
+          <a:xfrm>
+            <a:off x="6737560" y="2630000"/>
+            <a:ext cx="1183120" cy="780000"/>
+          </a:xfrm>
+          <a:prstGeom prst="roundRect">
+            <a:avLst/>
+          </a:prstGeom>
+          <a:solidFill>
+            <a:srgbClr val="FFFFFF"/>
+          </a:solidFill>
+          <a:ln w="9525">
+            <a:solidFill>
+              <a:srgbClr val="8971E1"/>
+            </a:solidFill>
+          </a:ln>
+          <a:effectLst/>
+        </p:spPr>
+        <p:style>
+          <a:lnRef idx="1">
+            <a:schemeClr val="accent1"/>
+          </a:lnRef>
+          <a:fillRef idx="3">
+            <a:schemeClr val="accent1"/>
+          </a:fillRef>
+          <a:effectRef idx="2">
+            <a:schemeClr val="accent1"/>
+          </a:effectRef>
+          <a:fontRef idx="minor">
+            <a:schemeClr val="lt1"/>
+          </a:fontRef>
+        </p:style>
+        <p:txBody>
+          <a:bodyPr rtlCol="0" anchor="ctr" wrap="square" lIns="45720" rIns="45720" tIns="22860" bIns="22860"/>
+          <a:lstStyle/>
+          <a:p>
+            <a:pPr algn="ctr"/>
+            <a:r>
+              <a:rPr sz="850" b="1">
+                <a:solidFill>
+                  <a:srgbClr val="95135A"/>
+                </a:solidFill>
+                <a:latin typeface="Open Sans"/>
+              </a:rPr>
+              <a:t>Rate Limits</a:t>
+            </a:r>
+          </a:p>
+          <a:p>
+            <a:pPr algn="ctr"/>
+            <a:r>
+              <a:rPr sz="650" b="0">
+                <a:solidFill>
+                  <a:srgbClr val="454551"/>
+                </a:solidFill>
+                <a:latin typeface="Open Sans"/>
+              </a:rPr>
+              <a:t>Throttle requests exceeding allowed pace</a:t>
+            </a:r>
+          </a:p>
+        </p:txBody>
+      </p:sp>
+      <p:sp>
+        <p:nvSpPr>
+          <p:cNvPr id="15" name="Right Arrow 14"/>
+          <p:cNvSpPr/>
+          <p:nvPr/>
+        </p:nvSpPr>
+        <p:spPr>
+          <a:xfrm>
+            <a:off x="7920680" y="2975000"/>
+            <a:ext cx="150000" cy="90000"/>
+          </a:xfrm>
+          <a:prstGeom prst="rightArrow">
+            <a:avLst/>
+          </a:prstGeom>
+          <a:solidFill>
+            <a:srgbClr val="8971E1"/>
+          </a:solidFill>
+          <a:ln>
+            <a:noFill/>
+          </a:ln>
+          <a:effectLst/>
+        </p:spPr>
+        <p:style>
+          <a:lnRef idx="1">
+            <a:schemeClr val="accent1"/>
+          </a:lnRef>
+          <a:fillRef idx="3">
+            <a:schemeClr val="accent1"/>
+          </a:fillRef>
+          <a:effectRef idx="2">
+            <a:schemeClr val="accent1"/>
+          </a:effectRef>
+          <a:fontRef idx="minor">
+            <a:schemeClr val="lt1"/>
+          </a:fontRef>
+        </p:style>
+        <p:txBody>
+          <a:bodyPr rtlCol="0" anchor="ctr"/>
+          <a:lstStyle/>
+          <a:p>
+            <a:pPr algn="ctr"/>
+          </a:p>
+        </p:txBody>
+      </p:sp>
+      <p:sp>
+        <p:nvSpPr>
+          <p:cNvPr id="16" name="Rounded Rectangle 15"/>
+          <p:cNvSpPr/>
+          <p:nvPr/>
+        </p:nvSpPr>
+        <p:spPr>
+          <a:xfrm>
+            <a:off x="8070680" y="2630000"/>
+            <a:ext cx="1183120" cy="780000"/>
+          </a:xfrm>
+          <a:prstGeom prst="roundRect">
+            <a:avLst/>
+          </a:prstGeom>
+          <a:solidFill>
+            <a:srgbClr val="FFFFFF"/>
+          </a:solidFill>
+          <a:ln w="9525">
+            <a:solidFill>
+              <a:srgbClr val="8971E1"/>
+            </a:solidFill>
+          </a:ln>
+          <a:effectLst/>
+        </p:spPr>
+        <p:style>
+          <a:lnRef idx="1">
+            <a:schemeClr val="accent1"/>
+          </a:lnRef>
+          <a:fillRef idx="3">
+            <a:schemeClr val="accent1"/>
+          </a:fillRef>
+          <a:effectRef idx="2">
+            <a:schemeClr val="accent1"/>
+          </a:effectRef>
+          <a:fontRef idx="minor">
+            <a:schemeClr val="lt1"/>
+          </a:fontRef>
+        </p:style>
+        <p:txBody>
+          <a:bodyPr rtlCol="0" anchor="ctr" wrap="square" lIns="45720" rIns="45720" tIns="22860" bIns="22860"/>
+          <a:lstStyle/>
+          <a:p>
+            <a:pPr algn="ctr"/>
+            <a:r>
+              <a:rPr sz="850" b="1">
+                <a:solidFill>
+                  <a:srgbClr val="95135A"/>
+                </a:solidFill>
+                <a:latin typeface="Open Sans"/>
+              </a:rPr>
+              <a:t>PII Protection</a:t>
+            </a:r>
+          </a:p>
+          <a:p>
+            <a:pPr algn="ctr"/>
+            <a:r>
+              <a:rPr sz="650" b="0">
+                <a:solidFill>
+                  <a:srgbClr val="454551"/>
+                </a:solidFill>
+                <a:latin typeface="Open Sans"/>
+              </a:rPr>
+              <a:t>Mask or block sensitive data before forwarding</a:t>
+            </a:r>
+          </a:p>
+        </p:txBody>
+      </p:sp>
+      <p:sp>
+        <p:nvSpPr>
+          <p:cNvPr id="17" name="Right Arrow 16"/>
+          <p:cNvSpPr/>
+          <p:nvPr/>
+        </p:nvSpPr>
+        <p:spPr>
+          <a:xfrm>
+            <a:off x="2368200" y="2765000"/>
+            <a:ext cx="190000" cy="120000"/>
+          </a:xfrm>
+          <a:prstGeom prst="rightArrow">
+            <a:avLst/>
+          </a:prstGeom>
+          <a:solidFill>
+            <a:srgbClr val="95135A"/>
+          </a:solidFill>
+          <a:ln>
+            <a:noFill/>
+          </a:ln>
+          <a:effectLst/>
+        </p:spPr>
+        <p:style>
+          <a:lnRef idx="1">
+            <a:schemeClr val="accent1"/>
+          </a:lnRef>
+          <a:fillRef idx="3">
+            <a:schemeClr val="accent1"/>
+          </a:fillRef>
+          <a:effectRef idx="2">
+            <a:schemeClr val="accent1"/>
+          </a:effectRef>
+          <a:fontRef idx="minor">
+            <a:schemeClr val="lt1"/>
+          </a:fontRef>
+        </p:style>
+        <p:txBody>
+          <a:bodyPr rtlCol="0" anchor="ctr"/>
+          <a:lstStyle/>
+          <a:p>
+            <a:pPr algn="ctr"/>
+          </a:p>
+        </p:txBody>
+      </p:sp>
+      <p:sp>
+        <p:nvSpPr>
+          <p:cNvPr id="18" name="Right Arrow 17"/>
+          <p:cNvSpPr/>
+          <p:nvPr/>
+        </p:nvSpPr>
+        <p:spPr>
+          <a:xfrm>
+            <a:off x="9433800" y="2765000"/>
+            <a:ext cx="190000" cy="120000"/>
+          </a:xfrm>
+          <a:prstGeom prst="rightArrow">
+            <a:avLst/>
+          </a:prstGeom>
+          <a:solidFill>
+            <a:srgbClr val="95135A"/>
+          </a:solidFill>
+          <a:ln>
+            <a:noFill/>
+          </a:ln>
+          <a:effectLst/>
+        </p:spPr>
+        <p:style>
+          <a:lnRef idx="1">
+            <a:schemeClr val="accent1"/>
+          </a:lnRef>
+          <a:fillRef idx="3">
+            <a:schemeClr val="accent1"/>
+          </a:fillRef>
+          <a:effectRef idx="2">
+            <a:schemeClr val="accent1"/>
+          </a:effectRef>
+          <a:fontRef idx="minor">
+            <a:schemeClr val="lt1"/>
+          </a:fontRef>
+        </p:style>
+        <p:txBody>
+          <a:bodyPr rtlCol="0" anchor="ctr"/>
+          <a:lstStyle/>
+          <a:p>
+            <a:pPr algn="ctr"/>
+          </a:p>
+        </p:txBody>
+      </p:sp>
+      <p:sp>
+        <p:nvSpPr>
+          <p:cNvPr id="19" name="TextBox 18"/>
+          <p:cNvSpPr txBox="1"/>
+          <p:nvPr/>
+        </p:nvSpPr>
+        <p:spPr>
+          <a:xfrm>
+            <a:off x="838200" y="1920000"/>
+            <a:ext cx="10515600" cy="220000"/>
+          </a:xfrm>
+          <a:prstGeom prst="rect">
+            <a:avLst/>
+          </a:prstGeom>
+          <a:noFill/>
+        </p:spPr>
+        <p:txBody>
+          <a:bodyPr wrap="none">
+            <a:spAutoFit/>
+          </a:bodyPr>
+          <a:lstStyle/>
+          <a:p>
+            <a:pPr algn="ctr"/>
+            <a:r>
+              <a:rPr sz="800" i="1">
+                <a:solidFill>
+                  <a:srgbClr val="454551"/>
+                </a:solidFill>
+                <a:latin typeface="Open Sans"/>
+              </a:rPr>
+              <a:t>Request flows left to right  •  Response &amp; enforcement decisions flow back to the client</a:t>
+            </a:r>
+          </a:p>
+        </p:txBody>
+      </p:sp>
+      <p:sp>
+        <p:nvSpPr>
+          <p:cNvPr id="20" name="Rounded Rectangle 19"/>
+          <p:cNvSpPr/>
+          <p:nvPr/>
+        </p:nvSpPr>
+        <p:spPr>
+          <a:xfrm>
+            <a:off x="2588200" y="3820000"/>
+            <a:ext cx="3332800" cy="850000"/>
+          </a:xfrm>
+          <a:prstGeom prst="roundRect">
+            <a:avLst/>
+          </a:prstGeom>
+          <a:solidFill>
+            <a:srgbClr val="ECE8FF"/>
+          </a:solidFill>
+          <a:ln w="12700">
+            <a:solidFill>
+              <a:srgbClr val="8971E1"/>
+            </a:solidFill>
+          </a:ln>
+          <a:effectLst/>
+        </p:spPr>
+        <p:style>
+          <a:lnRef idx="1">
+            <a:schemeClr val="accent1"/>
+          </a:lnRef>
+          <a:fillRef idx="3">
+            <a:schemeClr val="accent1"/>
+          </a:fillRef>
+          <a:effectRef idx="2">
+            <a:schemeClr val="accent1"/>
+          </a:effectRef>
+          <a:fontRef idx="minor">
+            <a:schemeClr val="lt1"/>
+          </a:fontRef>
+        </p:style>
+        <p:txBody>
+          <a:bodyPr rtlCol="0" anchor="ctr" wrap="square" lIns="45720" rIns="45720" tIns="22860" bIns="22860"/>
+          <a:lstStyle/>
+          <a:p>
+            <a:pPr algn="ctr"/>
+            <a:r>
+              <a:rPr sz="950" b="1">
+                <a:solidFill>
+                  <a:srgbClr val="8971E1"/>
+                </a:solidFill>
+                <a:latin typeface="Open Sans"/>
+              </a:rPr>
+              <a:t>Cost &amp; Token Accounting</a:t>
+            </a:r>
+          </a:p>
+          <a:p>
+            <a:pPr algn="ctr"/>
+            <a:r>
+              <a:rPr sz="750" b="0">
+                <a:solidFill>
+                  <a:srgbClr val="454551"/>
+                </a:solidFill>
+                <a:latin typeface="Open Sans"/>
+              </a:rPr>
+              <a:t>Calculates usage and cost from each response</a:t>
+            </a:r>
+          </a:p>
+        </p:txBody>
+      </p:sp>
+      <p:sp>
+        <p:nvSpPr>
+          <p:cNvPr id="21" name="Rounded Rectangle 20"/>
+          <p:cNvSpPr/>
+          <p:nvPr/>
+        </p:nvSpPr>
+        <p:spPr>
+          <a:xfrm>
+            <a:off x="6071000" y="3820000"/>
+            <a:ext cx="3332800" cy="850000"/>
+          </a:xfrm>
+          <a:prstGeom prst="roundRect">
+            <a:avLst/>
+          </a:prstGeom>
+          <a:solidFill>
+            <a:srgbClr val="ECE8FF"/>
+          </a:solidFill>
+          <a:ln w="12700">
+            <a:solidFill>
+              <a:srgbClr val="8971E1"/>
+            </a:solidFill>
+          </a:ln>
+          <a:effectLst/>
+        </p:spPr>
+        <p:style>
+          <a:lnRef idx="1">
+            <a:schemeClr val="accent1"/>
+          </a:lnRef>
+          <a:fillRef idx="3">
+            <a:schemeClr val="accent1"/>
+          </a:fillRef>
+          <a:effectRef idx="2">
+            <a:schemeClr val="accent1"/>
+          </a:effectRef>
+          <a:fontRef idx="minor">
+            <a:schemeClr val="lt1"/>
+          </a:fontRef>
+        </p:style>
+        <p:txBody>
+          <a:bodyPr rtlCol="0" anchor="ctr" wrap="square" lIns="45720" rIns="45720" tIns="22860" bIns="22860"/>
+          <a:lstStyle/>
+          <a:p>
+            <a:pPr algn="ctr"/>
+            <a:r>
+              <a:rPr sz="950" b="1">
+                <a:solidFill>
+                  <a:srgbClr val="8971E1"/>
+                </a:solidFill>
+                <a:latin typeface="Open Sans"/>
+              </a:rPr>
+              <a:t>Audit &amp; Usage Logging</a:t>
+            </a:r>
+          </a:p>
+          <a:p>
+            <a:pPr algn="ctr"/>
+            <a:r>
+              <a:rPr sz="750" b="0">
+                <a:solidFill>
+                  <a:srgbClr val="454551"/>
+                </a:solidFill>
+                <a:latin typeface="Open Sans"/>
+              </a:rPr>
+              <a:t>Every decision and request is recorded for traceability</a:t>
+            </a:r>
+          </a:p>
+        </p:txBody>
+      </p:sp>
+      <p:sp>
+        <p:nvSpPr>
+          <p:cNvPr id="22" name="Right Arrow 21"/>
+          <p:cNvSpPr/>
+          <p:nvPr/>
+        </p:nvSpPr>
+        <p:spPr>
+          <a:xfrm rot="5400000">
+            <a:off x="4209600" y="3540000"/>
+            <a:ext cx="90000" cy="190000"/>
+          </a:xfrm>
+          <a:prstGeom prst="rightArrow">
+            <a:avLst/>
+          </a:prstGeom>
+          <a:solidFill>
+            <a:srgbClr val="8971E1"/>
+          </a:solidFill>
+          <a:ln>
+            <a:noFill/>
+          </a:ln>
+          <a:effectLst/>
+        </p:spPr>
+        <p:style>
+          <a:lnRef idx="1">
+            <a:schemeClr val="accent1"/>
+          </a:lnRef>
+          <a:fillRef idx="3">
+            <a:schemeClr val="accent1"/>
+          </a:fillRef>
+          <a:effectRef idx="2">
+            <a:schemeClr val="accent1"/>
+          </a:effectRef>
+          <a:fontRef idx="minor">
+            <a:schemeClr val="lt1"/>
+          </a:fontRef>
+        </p:style>
+        <p:txBody>
+          <a:bodyPr rtlCol="0" anchor="ctr"/>
+          <a:lstStyle/>
+          <a:p>
+            <a:pPr algn="ctr"/>
+          </a:p>
+        </p:txBody>
+      </p:sp>
+      <p:sp>
+        <p:nvSpPr>
+          <p:cNvPr id="23" name="Right Arrow 22"/>
+          <p:cNvSpPr/>
+          <p:nvPr/>
+        </p:nvSpPr>
+        <p:spPr>
+          <a:xfrm rot="5400000">
+            <a:off x="7692400" y="3540000"/>
+            <a:ext cx="90000" cy="190000"/>
+          </a:xfrm>
+          <a:prstGeom prst="rightArrow">
+            <a:avLst/>
+          </a:prstGeom>
+          <a:solidFill>
+            <a:srgbClr val="8971E1"/>
+          </a:solidFill>
+          <a:ln>
+            <a:noFill/>
+          </a:ln>
+          <a:effectLst/>
+        </p:spPr>
+        <p:style>
+          <a:lnRef idx="1">
+            <a:schemeClr val="accent1"/>
+          </a:lnRef>
+          <a:fillRef idx="3">
+            <a:schemeClr val="accent1"/>
+          </a:fillRef>
+          <a:effectRef idx="2">
+            <a:schemeClr val="accent1"/>
+          </a:effectRef>
+          <a:fontRef idx="minor">
+            <a:schemeClr val="lt1"/>
+          </a:fontRef>
+        </p:style>
+        <p:txBody>
+          <a:bodyPr rtlCol="0" anchor="ctr"/>
+          <a:lstStyle/>
+          <a:p>
+            <a:pPr algn="ctr"/>
+          </a:p>
+        </p:txBody>
+      </p:sp>
+      <p:sp>
+        <p:nvSpPr>
+          <p:cNvPr id="24" name="Rounded Rectangle 23"/>
+          <p:cNvSpPr/>
+          <p:nvPr/>
+        </p:nvSpPr>
+        <p:spPr>
+          <a:xfrm>
+            <a:off x="2588200" y="4990000"/>
+            <a:ext cx="6815600" cy="850000"/>
+          </a:xfrm>
+          <a:prstGeom prst="roundRect">
+            <a:avLst/>
+          </a:prstGeom>
+          <a:solidFill>
+            <a:srgbClr val="ECE8FF"/>
+          </a:solidFill>
+          <a:ln w="12700">
+            <a:solidFill>
+              <a:srgbClr val="8971E1"/>
+            </a:solidFill>
+          </a:ln>
+          <a:effectLst/>
+        </p:spPr>
+        <p:style>
+          <a:lnRef idx="1">
+            <a:schemeClr val="accent1"/>
+          </a:lnRef>
+          <a:fillRef idx="3">
+            <a:schemeClr val="accent1"/>
+          </a:fillRef>
+          <a:effectRef idx="2">
+            <a:schemeClr val="accent1"/>
+          </a:effectRef>
+          <a:fontRef idx="minor">
+            <a:schemeClr val="lt1"/>
+          </a:fontRef>
+        </p:style>
+        <p:txBody>
+          <a:bodyPr rtlCol="0" anchor="ctr" wrap="square" lIns="45720" rIns="45720" tIns="22860" bIns="22860"/>
+          <a:lstStyle/>
+          <a:p>
+            <a:pPr algn="ctr"/>
+            <a:r>
+              <a:rPr sz="1100" b="1">
                 <a:solidFill>
                   <a:srgbClr val="8971E1"/>
                 </a:solidFill>
@@ -5455,14 +6159,102 @@
           <a:p>
             <a:pPr algn="ctr"/>
             <a:r>
-              <a:rPr sz="850" b="0">
+              <a:rPr sz="800" b="0">
                 <a:solidFill>
                   <a:srgbClr val="454551"/>
                 </a:solidFill>
                 <a:latin typeface="Open Sans"/>
               </a:rPr>
-              <a:t>Real-time visibility into usage, cost, and compliance</a:t>
-            </a:r>
+              <a:t>Real-time visibility into usage, cost, spend trends &amp; compliance for administrators</a:t>
+            </a:r>
+          </a:p>
+        </p:txBody>
+      </p:sp>
+      <p:sp>
+        <p:nvSpPr>
+          <p:cNvPr id="25" name="Right Arrow 24"/>
+          <p:cNvSpPr/>
+          <p:nvPr/>
+        </p:nvSpPr>
+        <p:spPr>
+          <a:xfrm rot="5400000">
+            <a:off x="4209600" y="4710000"/>
+            <a:ext cx="90000" cy="190000"/>
+          </a:xfrm>
+          <a:prstGeom prst="rightArrow">
+            <a:avLst/>
+          </a:prstGeom>
+          <a:solidFill>
+            <a:srgbClr val="8971E1"/>
+          </a:solidFill>
+          <a:ln>
+            <a:noFill/>
+          </a:ln>
+          <a:effectLst/>
+        </p:spPr>
+        <p:style>
+          <a:lnRef idx="1">
+            <a:schemeClr val="accent1"/>
+          </a:lnRef>
+          <a:fillRef idx="3">
+            <a:schemeClr val="accent1"/>
+          </a:fillRef>
+          <a:effectRef idx="2">
+            <a:schemeClr val="accent1"/>
+          </a:effectRef>
+          <a:fontRef idx="minor">
+            <a:schemeClr val="lt1"/>
+          </a:fontRef>
+        </p:style>
+        <p:txBody>
+          <a:bodyPr rtlCol="0" anchor="ctr"/>
+          <a:lstStyle/>
+          <a:p>
+            <a:pPr algn="ctr"/>
+          </a:p>
+        </p:txBody>
+      </p:sp>
+      <p:sp>
+        <p:nvSpPr>
+          <p:cNvPr id="26" name="Right Arrow 25"/>
+          <p:cNvSpPr/>
+          <p:nvPr/>
+        </p:nvSpPr>
+        <p:spPr>
+          <a:xfrm rot="5400000">
+            <a:off x="7692400" y="4710000"/>
+            <a:ext cx="90000" cy="190000"/>
+          </a:xfrm>
+          <a:prstGeom prst="rightArrow">
+            <a:avLst/>
+          </a:prstGeom>
+          <a:solidFill>
+            <a:srgbClr val="8971E1"/>
+          </a:solidFill>
+          <a:ln>
+            <a:noFill/>
+          </a:ln>
+          <a:effectLst/>
+        </p:spPr>
+        <p:style>
+          <a:lnRef idx="1">
+            <a:schemeClr val="accent1"/>
+          </a:lnRef>
+          <a:fillRef idx="3">
+            <a:schemeClr val="accent1"/>
+          </a:fillRef>
+          <a:effectRef idx="2">
+            <a:schemeClr val="accent1"/>
+          </a:effectRef>
+          <a:fontRef idx="minor">
+            <a:schemeClr val="lt1"/>
+          </a:fontRef>
+        </p:style>
+        <p:txBody>
+          <a:bodyPr rtlCol="0" anchor="ctr"/>
+          <a:lstStyle/>
+          <a:p>
+            <a:pPr algn="ctr"/>
           </a:p>
         </p:txBody>
       </p:sp>

</xml_diff>

<commit_message>
updated backed to get indian time stamp
</commit_message>
<xml_diff>
--- a/Ampera AI Governance - Presentation.pptx
+++ b/Ampera AI Governance - Presentation.pptx
@@ -13,6 +13,7 @@
   <p:sldIdLst>
     <p:sldId id="266" r:id="rId14"/>
     <p:sldId id="267" r:id="rId15"/>
+    <p:sldId id="271" r:id="rId19"/>
     <p:sldId id="268" r:id="rId16"/>
     <p:sldId id="269" r:id="rId17"/>
     <p:sldId id="270" r:id="rId18"/>
@@ -6898,6 +6899,142 @@
           </a:prstGeom>
         </p:spPr>
       </p:pic>
+    </p:spTree>
+  </p:cSld>
+  <p:clrMapOvr>
+    <a:masterClrMapping/>
+  </p:clrMapOvr>
+</p:sld>
+</file>
+
+<file path=ppt/slides/slide7.xml><?xml version="1.0" encoding="utf-8"?>
+<p:sld xmlns:a="http://schemas.openxmlformats.org/drawingml/2006/main" xmlns:p="http://schemas.openxmlformats.org/presentationml/2006/main" xmlns:r="http://schemas.openxmlformats.org/officeDocument/2006/relationships">
+  <p:cSld>
+    <p:spTree>
+      <p:nvGrpSpPr>
+        <p:cNvPr id="1" name=""/>
+        <p:cNvGrpSpPr/>
+        <p:nvPr/>
+      </p:nvGrpSpPr>
+      <p:grpSpPr/>
+      <p:sp>
+        <p:nvSpPr>
+          <p:cNvPr id="2" name="Title 1"/>
+          <p:cNvSpPr>
+            <a:spLocks noGrp="1"/>
+          </p:cNvSpPr>
+          <p:nvPr>
+            <p:ph type="title"/>
+          </p:nvPr>
+        </p:nvSpPr>
+        <p:spPr/>
+        <p:txBody>
+          <a:bodyPr/>
+          <a:lstStyle/>
+          <a:p>
+            <a:r>
+              <a:rPr sz="2600" b="1">
+                <a:solidFill>
+                  <a:srgbClr val="95135A"/>
+                </a:solidFill>
+                <a:latin typeface="Open Sans"/>
+              </a:rPr>
+              <a:t>Problem, Solution &amp; Objection</a:t>
+            </a:r>
+          </a:p>
+        </p:txBody>
+      </p:sp>
+      <p:sp>
+        <p:nvSpPr>
+          <p:cNvPr id="3" name="Content Placeholder 2"/>
+          <p:cNvSpPr>
+            <a:spLocks noGrp="1"/>
+          </p:cNvSpPr>
+          <p:nvPr>
+            <p:ph idx="1"/>
+          </p:nvPr>
+        </p:nvSpPr>
+        <p:spPr/>
+        <p:txBody>
+          <a:bodyPr wrap="square"/>
+          <a:lstStyle/>
+          <a:p>
+            <a:pPr/>
+            <a:r>
+              <a:rPr sz="1400" b="1">
+                <a:solidFill>
+                  <a:srgbClr val="95135A"/>
+                </a:solidFill>
+                <a:latin typeface="Open Sans"/>
+              </a:rPr>
+              <a:t>Problem Statement</a:t>
+            </a:r>
+          </a:p>
+          <a:p>
+            <a:pPr lvl="1"/>
+            <a:r>
+              <a:rPr sz="1150" b="0">
+                <a:solidFill>
+                  <a:srgbClr val="454551"/>
+                </a:solidFill>
+                <a:latin typeface="Open Sans"/>
+              </a:rPr>
+              <a:t>Enterprise AI usage is fragmented and unmonitored — no visibility into spend, model access, or data exposure risk.</a:t>
+            </a:r>
+          </a:p>
+          <a:p/>
+          <a:p>
+            <a:pPr/>
+            <a:r>
+              <a:rPr sz="1400" b="1">
+                <a:solidFill>
+                  <a:srgbClr val="95135A"/>
+                </a:solidFill>
+                <a:latin typeface="Open Sans"/>
+              </a:rPr>
+              <a:t>Solution</a:t>
+            </a:r>
+          </a:p>
+          <a:p>
+            <a:pPr lvl="1"/>
+            <a:r>
+              <a:rPr sz="1150" b="0">
+                <a:solidFill>
+                  <a:srgbClr val="454551"/>
+                </a:solidFill>
+                <a:latin typeface="Open Sans"/>
+              </a:rPr>
+              <a:t>A centralized governance proxy enforces policy, budget, and PII controls on every request before it reaches the AI provider.</a:t>
+            </a:r>
+          </a:p>
+          <a:p/>
+          <a:p>
+            <a:pPr/>
+            <a:r>
+              <a:rPr sz="1400" b="1">
+                <a:solidFill>
+                  <a:srgbClr val="95135A"/>
+                </a:solidFill>
+                <a:latin typeface="Open Sans"/>
+              </a:rPr>
+              <a:t>Objection</a:t>
+            </a:r>
+          </a:p>
+          <a:p>
+            <a:pPr lvl="1"/>
+            <a:r>
+              <a:rPr sz="1150" b="0">
+                <a:solidFill>
+                  <a:srgbClr val="454551"/>
+                </a:solidFill>
+                <a:latin typeface="Open Sans"/>
+              </a:rPr>
+              <a:t>Won’t this slow things down? No — it runs in the background and teams won’t notice a difference.</a:t>
+            </a:r>
+          </a:p>
+          <a:p/>
+        </p:txBody>
+      </p:sp>
     </p:spTree>
   </p:cSld>
   <p:clrMapOvr>

</xml_diff>